<commit_message>
Update presentation with final repository URL
</commit_message>
<xml_diff>
--- a/presentation/DASC605_BYOD_Virginia_Airline_Delays.pptx
+++ b/presentation/DASC605_BYOD_Virginia_Airline_Delays.pptx
@@ -2,14 +2,14 @@
 <file path=ppt/presentation.xml><?xml version="1.0" encoding="utf-8"?>
 <p:presentation xmlns:p="http://schemas.openxmlformats.org/presentationml/2006/main">
   <p:sldMasterIdLst>
-    <p:sldMasterId xmlns:r="http://schemas.openxmlformats.org/officeDocument/2006/relationships" id="2147483648" r:id="R90f97219dc204e66"/>
+    <p:sldMasterId xmlns:r="http://schemas.openxmlformats.org/officeDocument/2006/relationships" id="2147483648" r:id="R6b051ab4cfba42b0"/>
   </p:sldMasterIdLst>
   <p:notesMasterIdLst>
-    <p:notesMasterId xmlns:r="http://schemas.openxmlformats.org/officeDocument/2006/relationships" r:id="R62d065bdad6e4a96"/>
+    <p:notesMasterId xmlns:r="http://schemas.openxmlformats.org/officeDocument/2006/relationships" r:id="R3a516f7e3fcc41c3"/>
   </p:notesMasterIdLst>
   <p:sldIdLst>
-    <p:sldId xmlns:r="http://schemas.openxmlformats.org/officeDocument/2006/relationships" id="256" r:id="Rcb0ac89ece4441fe"/>
-    <p:sldId xmlns:r="http://schemas.openxmlformats.org/officeDocument/2006/relationships" id="257" r:id="Re3c91957c2954b31"/>
+    <p:sldId xmlns:r="http://schemas.openxmlformats.org/officeDocument/2006/relationships" id="256" r:id="Ref0ee66e314b44be"/>
+    <p:sldId xmlns:r="http://schemas.openxmlformats.org/officeDocument/2006/relationships" id="257" r:id="Ra967b5e29fd44aeb"/>
   </p:sldIdLst>
   <p:sldSz cx="12192000" cy="6858000"/>
   <p:notesSz cx="6858000" cy="9144000"/>
@@ -641,7 +641,7 @@
   </p:cSld>
   <p:clrMap bg1="lt1" tx1="dk1" bg2="lt2" tx2="dk2" accent1="accent1" accent2="accent2" accent3="accent3" accent4="accent4" accent5="accent5" accent6="accent6" hlink="hlink" folHlink="folHlink"/>
   <p:sldLayoutIdLst>
-    <p:sldLayoutId xmlns:r="http://schemas.openxmlformats.org/officeDocument/2006/relationships" id="2147483649" r:id="Rf60488fa02a940d9"/>
+    <p:sldLayoutId xmlns:r="http://schemas.openxmlformats.org/officeDocument/2006/relationships" id="2147483649" r:id="Ra06777fc910041d0"/>
   </p:sldLayoutIdLst>
   <p:txStyles>
     <p:titleStyle>
@@ -1192,7 +1192,7 @@
           <p:cNvPr id="21" name="">
             <a:extLst xmlns:a="http://schemas.openxmlformats.org/drawingml/2006/main">
               <a:ext uri="{FF2B5EF4-FFF2-40B4-BE49-F238E27FC236}">
-                <a16:creationId xmlns:a16="http://schemas.microsoft.com/office/drawing/2014/main" id="{CCAF5320-9025-471F-A4FF-04FAF671A621}"/>
+                <a16:creationId xmlns:a16="http://schemas.microsoft.com/office/drawing/2014/main" id="{F9F5444B-1CAE-4D53-BBF1-190D2B744EC9}"/>
               </a:ext>
             </a:extLst>
           </p:cNvPr>
@@ -1242,7 +1242,7 @@
           <p:cNvPr id="2" name="">
             <a:extLst xmlns:a="http://schemas.openxmlformats.org/drawingml/2006/main">
               <a:ext uri="{FF2B5EF4-FFF2-40B4-BE49-F238E27FC236}">
-                <a16:creationId xmlns:a16="http://schemas.microsoft.com/office/drawing/2014/main" id="{A6CEF3DF-FADA-406E-9A14-7BD77CEF32B6}"/>
+                <a16:creationId xmlns:a16="http://schemas.microsoft.com/office/drawing/2014/main" id="{4093B719-7995-4A49-9AEB-81286759AFF7}"/>
               </a:ext>
             </a:extLst>
           </p:cNvPr>
@@ -1292,7 +1292,7 @@
           <p:cNvPr id="3" name="">
             <a:extLst xmlns:a="http://schemas.openxmlformats.org/drawingml/2006/main">
               <a:ext uri="{FF2B5EF4-FFF2-40B4-BE49-F238E27FC236}">
-                <a16:creationId xmlns:a16="http://schemas.microsoft.com/office/drawing/2014/main" id="{C859B84C-7F04-4643-87C2-4215CCB83805}"/>
+                <a16:creationId xmlns:a16="http://schemas.microsoft.com/office/drawing/2014/main" id="{5745C5B9-77D3-4460-AA5D-517F3B05DDB3}"/>
               </a:ext>
             </a:extLst>
           </p:cNvPr>
@@ -1342,7 +1342,7 @@
           <p:cNvPr id="4" name="">
             <a:extLst xmlns:a="http://schemas.openxmlformats.org/drawingml/2006/main">
               <a:ext uri="{FF2B5EF4-FFF2-40B4-BE49-F238E27FC236}">
-                <a16:creationId xmlns:a16="http://schemas.microsoft.com/office/drawing/2014/main" id="{25869FC0-7109-476D-906B-392B2189FDE7}"/>
+                <a16:creationId xmlns:a16="http://schemas.microsoft.com/office/drawing/2014/main" id="{BF9620F9-CB48-4BC6-9177-C82C443F8DC7}"/>
               </a:ext>
             </a:extLst>
           </p:cNvPr>
@@ -1375,7 +1375,7 @@
           <p:cNvPr id="5" name="">
             <a:extLst xmlns:a="http://schemas.openxmlformats.org/drawingml/2006/main">
               <a:ext uri="{FF2B5EF4-FFF2-40B4-BE49-F238E27FC236}">
-                <a16:creationId xmlns:a16="http://schemas.microsoft.com/office/drawing/2014/main" id="{A533B6F7-9B3B-4617-A54D-FF6F02DDFA59}"/>
+                <a16:creationId xmlns:a16="http://schemas.microsoft.com/office/drawing/2014/main" id="{9EE88143-E108-44BF-94C3-3E18A9D601D2}"/>
               </a:ext>
             </a:extLst>
           </p:cNvPr>
@@ -1425,7 +1425,7 @@
           <p:cNvPr id="6" name="">
             <a:extLst xmlns:a="http://schemas.openxmlformats.org/drawingml/2006/main">
               <a:ext uri="{FF2B5EF4-FFF2-40B4-BE49-F238E27FC236}">
-                <a16:creationId xmlns:a16="http://schemas.microsoft.com/office/drawing/2014/main" id="{027BF535-BD12-4060-8CFF-7EDDE21694E0}"/>
+                <a16:creationId xmlns:a16="http://schemas.microsoft.com/office/drawing/2014/main" id="{0ABA3DC1-0EAB-4483-A018-048D38C361DE}"/>
               </a:ext>
             </a:extLst>
           </p:cNvPr>
@@ -1460,7 +1460,7 @@
           <p:cNvPr id="7" name="">
             <a:extLst xmlns:a="http://schemas.openxmlformats.org/drawingml/2006/main">
               <a:ext uri="{FF2B5EF4-FFF2-40B4-BE49-F238E27FC236}">
-                <a16:creationId xmlns:a16="http://schemas.microsoft.com/office/drawing/2014/main" id="{9829B803-6C0B-46F6-8B77-F041DB4FEEA5}"/>
+                <a16:creationId xmlns:a16="http://schemas.microsoft.com/office/drawing/2014/main" id="{3365F86E-BDAF-44E9-9443-D7C417CB9571}"/>
               </a:ext>
             </a:extLst>
           </p:cNvPr>
@@ -1510,7 +1510,7 @@
           <p:cNvPr id="8" name="">
             <a:extLst xmlns:a="http://schemas.openxmlformats.org/drawingml/2006/main">
               <a:ext uri="{FF2B5EF4-FFF2-40B4-BE49-F238E27FC236}">
-                <a16:creationId xmlns:a16="http://schemas.microsoft.com/office/drawing/2014/main" id="{BF747F8A-830A-4DE1-A457-8059E0D53AC4}"/>
+                <a16:creationId xmlns:a16="http://schemas.microsoft.com/office/drawing/2014/main" id="{DB025400-D5BE-41EF-AE05-27E3E177F26A}"/>
               </a:ext>
             </a:extLst>
           </p:cNvPr>
@@ -1577,7 +1577,7 @@
           <p:cNvPr id="9" name="">
             <a:extLst xmlns:a="http://schemas.openxmlformats.org/drawingml/2006/main">
               <a:ext uri="{FF2B5EF4-FFF2-40B4-BE49-F238E27FC236}">
-                <a16:creationId xmlns:a16="http://schemas.microsoft.com/office/drawing/2014/main" id="{1DF59D6C-A8F5-44B1-9AFC-2D60C699F2BD}"/>
+                <a16:creationId xmlns:a16="http://schemas.microsoft.com/office/drawing/2014/main" id="{6817BC41-9FD3-4E81-A75D-90B22689D1C6}"/>
               </a:ext>
             </a:extLst>
           </p:cNvPr>
@@ -1627,7 +1627,7 @@
           <p:cNvPr id="10" name="">
             <a:extLst xmlns:a="http://schemas.openxmlformats.org/drawingml/2006/main">
               <a:ext uri="{FF2B5EF4-FFF2-40B4-BE49-F238E27FC236}">
-                <a16:creationId xmlns:a16="http://schemas.microsoft.com/office/drawing/2014/main" id="{1069F30C-F1A9-4F8E-975A-B01FB859121D}"/>
+                <a16:creationId xmlns:a16="http://schemas.microsoft.com/office/drawing/2014/main" id="{56B2A187-F929-4C08-86E4-E1531099ED37}"/>
               </a:ext>
             </a:extLst>
           </p:cNvPr>
@@ -1677,7 +1677,7 @@
           <p:cNvPr id="11" name="">
             <a:extLst xmlns:a="http://schemas.openxmlformats.org/drawingml/2006/main">
               <a:ext uri="{FF2B5EF4-FFF2-40B4-BE49-F238E27FC236}">
-                <a16:creationId xmlns:a16="http://schemas.microsoft.com/office/drawing/2014/main" id="{7A4CD24F-5EEA-4A69-BD57-C358A7859A50}"/>
+                <a16:creationId xmlns:a16="http://schemas.microsoft.com/office/drawing/2014/main" id="{E10638C0-3E00-4705-A86D-8E8D01FEC5EF}"/>
               </a:ext>
             </a:extLst>
           </p:cNvPr>
@@ -1727,7 +1727,7 @@
           <p:cNvPr id="12" name="">
             <a:extLst xmlns:a="http://schemas.openxmlformats.org/drawingml/2006/main">
               <a:ext uri="{FF2B5EF4-FFF2-40B4-BE49-F238E27FC236}">
-                <a16:creationId xmlns:a16="http://schemas.microsoft.com/office/drawing/2014/main" id="{CD6CDDF3-3D77-4D58-99A9-871D7F130B85}"/>
+                <a16:creationId xmlns:a16="http://schemas.microsoft.com/office/drawing/2014/main" id="{A61DB568-A583-402F-869C-622A2A407FAF}"/>
               </a:ext>
             </a:extLst>
           </p:cNvPr>
@@ -1777,7 +1777,7 @@
           <p:cNvPr id="13" name="">
             <a:extLst xmlns:a="http://schemas.openxmlformats.org/drawingml/2006/main">
               <a:ext uri="{FF2B5EF4-FFF2-40B4-BE49-F238E27FC236}">
-                <a16:creationId xmlns:a16="http://schemas.microsoft.com/office/drawing/2014/main" id="{F516D7F0-91A8-4FB0-8A8E-5EA2C1AF90E4}"/>
+                <a16:creationId xmlns:a16="http://schemas.microsoft.com/office/drawing/2014/main" id="{E48532B4-D4EB-411F-9590-07E41BA86B3A}"/>
               </a:ext>
             </a:extLst>
           </p:cNvPr>
@@ -1827,7 +1827,7 @@
           <p:cNvPr id="14" name="">
             <a:extLst xmlns:a="http://schemas.openxmlformats.org/drawingml/2006/main">
               <a:ext uri="{FF2B5EF4-FFF2-40B4-BE49-F238E27FC236}">
-                <a16:creationId xmlns:a16="http://schemas.microsoft.com/office/drawing/2014/main" id="{6F87F998-C120-4E71-8AB4-20AE8E3CB2C3}"/>
+                <a16:creationId xmlns:a16="http://schemas.microsoft.com/office/drawing/2014/main" id="{17807437-D303-4DEE-9D3A-CD9C5ACE1B7C}"/>
               </a:ext>
             </a:extLst>
           </p:cNvPr>
@@ -1877,7 +1877,7 @@
           <p:cNvPr id="15" name="">
             <a:extLst xmlns:a="http://schemas.openxmlformats.org/drawingml/2006/main">
               <a:ext uri="{FF2B5EF4-FFF2-40B4-BE49-F238E27FC236}">
-                <a16:creationId xmlns:a16="http://schemas.microsoft.com/office/drawing/2014/main" id="{3B567457-6466-4BCC-B932-8DA0572B32EE}"/>
+                <a16:creationId xmlns:a16="http://schemas.microsoft.com/office/drawing/2014/main" id="{0137CF39-E7EE-48B2-ADF9-A994ADC198CA}"/>
               </a:ext>
             </a:extLst>
           </p:cNvPr>
@@ -1927,7 +1927,7 @@
           <p:cNvPr id="16" name="">
             <a:extLst xmlns:a="http://schemas.openxmlformats.org/drawingml/2006/main">
               <a:ext uri="{FF2B5EF4-FFF2-40B4-BE49-F238E27FC236}">
-                <a16:creationId xmlns:a16="http://schemas.microsoft.com/office/drawing/2014/main" id="{802A6253-D018-4044-860F-3316A18F4255}"/>
+                <a16:creationId xmlns:a16="http://schemas.microsoft.com/office/drawing/2014/main" id="{31AC54A4-A8C6-4EBD-95DC-6033D31C7C45}"/>
               </a:ext>
             </a:extLst>
           </p:cNvPr>
@@ -1977,7 +1977,7 @@
           <p:cNvPr id="17" name="">
             <a:extLst xmlns:a="http://schemas.openxmlformats.org/drawingml/2006/main">
               <a:ext uri="{FF2B5EF4-FFF2-40B4-BE49-F238E27FC236}">
-                <a16:creationId xmlns:a16="http://schemas.microsoft.com/office/drawing/2014/main" id="{34F8FB4A-0FCE-43FC-BDA8-B30B0FA05362}"/>
+                <a16:creationId xmlns:a16="http://schemas.microsoft.com/office/drawing/2014/main" id="{442339BE-EF17-4D38-B50B-0AF2F7C005EA}"/>
               </a:ext>
             </a:extLst>
           </p:cNvPr>
@@ -2012,7 +2012,7 @@
           <p:cNvPr id="18" name="">
             <a:extLst xmlns:a="http://schemas.openxmlformats.org/drawingml/2006/main">
               <a:ext uri="{FF2B5EF4-FFF2-40B4-BE49-F238E27FC236}">
-                <a16:creationId xmlns:a16="http://schemas.microsoft.com/office/drawing/2014/main" id="{655185D4-10CF-47D7-A0F5-0B512EB552E6}"/>
+                <a16:creationId xmlns:a16="http://schemas.microsoft.com/office/drawing/2014/main" id="{4A2621D3-19A2-4852-B1A9-360420AC13FC}"/>
               </a:ext>
             </a:extLst>
           </p:cNvPr>
@@ -2062,7 +2062,7 @@
           <p:cNvPr id="19" name="">
             <a:extLst xmlns:a="http://schemas.openxmlformats.org/drawingml/2006/main">
               <a:ext uri="{FF2B5EF4-FFF2-40B4-BE49-F238E27FC236}">
-                <a16:creationId xmlns:a16="http://schemas.microsoft.com/office/drawing/2014/main" id="{B97FFBB3-197D-4C96-82F7-91ED339B68A1}"/>
+                <a16:creationId xmlns:a16="http://schemas.microsoft.com/office/drawing/2014/main" id="{D31ECBD3-6460-4DDC-B1E1-4A3F9439B778}"/>
               </a:ext>
             </a:extLst>
           </p:cNvPr>
@@ -2112,7 +2112,7 @@
           <p:cNvPr id="20" name="">
             <a:extLst xmlns:a="http://schemas.openxmlformats.org/drawingml/2006/main">
               <a:ext uri="{FF2B5EF4-FFF2-40B4-BE49-F238E27FC236}">
-                <a16:creationId xmlns:a16="http://schemas.microsoft.com/office/drawing/2014/main" id="{BC211CC8-EBFC-496B-B8BB-AB4F642CAE5D}"/>
+                <a16:creationId xmlns:a16="http://schemas.microsoft.com/office/drawing/2014/main" id="{1F724DFF-F117-4808-A86A-5CCA38F01165}"/>
               </a:ext>
             </a:extLst>
           </p:cNvPr>
@@ -2160,7 +2160,7 @@
     </p:spTree>
     <p:extLst>
       <p:ext uri="{BB962C8B-B14F-4D97-AF65-F5344CB8AC3E}">
-        <p14:creationId xmlns:p14="http://schemas.microsoft.com/office/powerpoint/2010/main" val="2019087071"/>
+        <p14:creationId xmlns:p14="http://schemas.microsoft.com/office/powerpoint/2010/main" val="518527006"/>
       </p:ext>
     </p:extLst>
   </p:cSld>
@@ -2191,7 +2191,7 @@
           <p:cNvPr id="32" name="">
             <a:extLst xmlns:a="http://schemas.openxmlformats.org/drawingml/2006/main">
               <a:ext uri="{FF2B5EF4-FFF2-40B4-BE49-F238E27FC236}">
-                <a16:creationId xmlns:a16="http://schemas.microsoft.com/office/drawing/2014/main" id="{D1557A44-9334-4C52-AA13-BEBCB9C40EA3}"/>
+                <a16:creationId xmlns:a16="http://schemas.microsoft.com/office/drawing/2014/main" id="{1BEA4C78-F263-4CD8-A7D7-BC8AE8605F5D}"/>
               </a:ext>
             </a:extLst>
           </p:cNvPr>
@@ -2241,7 +2241,7 @@
           <p:cNvPr id="2" name="">
             <a:extLst xmlns:a="http://schemas.openxmlformats.org/drawingml/2006/main">
               <a:ext uri="{FF2B5EF4-FFF2-40B4-BE49-F238E27FC236}">
-                <a16:creationId xmlns:a16="http://schemas.microsoft.com/office/drawing/2014/main" id="{4C8441A7-0FE0-4AF2-ACA1-8283EBAD14B5}"/>
+                <a16:creationId xmlns:a16="http://schemas.microsoft.com/office/drawing/2014/main" id="{24641F01-8C24-4903-805D-2307FF83B5A0}"/>
               </a:ext>
             </a:extLst>
           </p:cNvPr>
@@ -2291,7 +2291,7 @@
           <p:cNvPr id="3" name="">
             <a:extLst xmlns:a="http://schemas.openxmlformats.org/drawingml/2006/main">
               <a:ext uri="{FF2B5EF4-FFF2-40B4-BE49-F238E27FC236}">
-                <a16:creationId xmlns:a16="http://schemas.microsoft.com/office/drawing/2014/main" id="{B7B4795F-5A37-4A4F-B5A1-68F929AF944B}"/>
+                <a16:creationId xmlns:a16="http://schemas.microsoft.com/office/drawing/2014/main" id="{96079D41-6CD3-4B73-95E6-1543896AF810}"/>
               </a:ext>
             </a:extLst>
           </p:cNvPr>
@@ -2341,7 +2341,7 @@
           <p:cNvPr id="4" name="">
             <a:extLst xmlns:a="http://schemas.openxmlformats.org/drawingml/2006/main">
               <a:ext uri="{FF2B5EF4-FFF2-40B4-BE49-F238E27FC236}">
-                <a16:creationId xmlns:a16="http://schemas.microsoft.com/office/drawing/2014/main" id="{3E904A41-9C78-4610-9CF1-F12662BA61D1}"/>
+                <a16:creationId xmlns:a16="http://schemas.microsoft.com/office/drawing/2014/main" id="{18AA2B89-6755-465A-A8E8-479A9CDB6379}"/>
               </a:ext>
             </a:extLst>
           </p:cNvPr>
@@ -2374,7 +2374,7 @@
           <p:cNvPr id="5" name="">
             <a:extLst xmlns:a="http://schemas.openxmlformats.org/drawingml/2006/main">
               <a:ext uri="{FF2B5EF4-FFF2-40B4-BE49-F238E27FC236}">
-                <a16:creationId xmlns:a16="http://schemas.microsoft.com/office/drawing/2014/main" id="{1EE0F3EA-4F57-4E94-BBF0-6654D56B4A37}"/>
+                <a16:creationId xmlns:a16="http://schemas.microsoft.com/office/drawing/2014/main" id="{B48B67F9-BC8B-4387-9E39-CD1F4B3EBB52}"/>
               </a:ext>
             </a:extLst>
           </p:cNvPr>
@@ -2409,7 +2409,7 @@
           <p:cNvPr id="6" name="">
             <a:extLst xmlns:a="http://schemas.openxmlformats.org/drawingml/2006/main">
               <a:ext uri="{FF2B5EF4-FFF2-40B4-BE49-F238E27FC236}">
-                <a16:creationId xmlns:a16="http://schemas.microsoft.com/office/drawing/2014/main" id="{143FDC71-2056-4DBA-8312-89415A4A9229}"/>
+                <a16:creationId xmlns:a16="http://schemas.microsoft.com/office/drawing/2014/main" id="{0EA82356-5F29-4274-93BC-DD1C43657BB8}"/>
               </a:ext>
             </a:extLst>
           </p:cNvPr>
@@ -2459,7 +2459,7 @@
           <p:cNvPr id="7" name="">
             <a:extLst xmlns:a="http://schemas.openxmlformats.org/drawingml/2006/main">
               <a:ext uri="{FF2B5EF4-FFF2-40B4-BE49-F238E27FC236}">
-                <a16:creationId xmlns:a16="http://schemas.microsoft.com/office/drawing/2014/main" id="{570DC977-BD53-48BE-B526-739E95F82B5A}"/>
+                <a16:creationId xmlns:a16="http://schemas.microsoft.com/office/drawing/2014/main" id="{5439C4BD-E9A3-44BA-BAA4-C0E0D9CB70B9}"/>
               </a:ext>
             </a:extLst>
           </p:cNvPr>
@@ -2509,7 +2509,7 @@
           <p:cNvPr id="8" name="">
             <a:extLst xmlns:a="http://schemas.openxmlformats.org/drawingml/2006/main">
               <a:ext uri="{FF2B5EF4-FFF2-40B4-BE49-F238E27FC236}">
-                <a16:creationId xmlns:a16="http://schemas.microsoft.com/office/drawing/2014/main" id="{30B6AD96-CB31-45FB-BE9C-2AF7CD6DFA9A}"/>
+                <a16:creationId xmlns:a16="http://schemas.microsoft.com/office/drawing/2014/main" id="{EEAC9161-2287-4736-BC9C-443A147F77D3}"/>
               </a:ext>
             </a:extLst>
           </p:cNvPr>
@@ -2559,7 +2559,7 @@
           <p:cNvPr id="9" name="">
             <a:extLst xmlns:a="http://schemas.openxmlformats.org/drawingml/2006/main">
               <a:ext uri="{FF2B5EF4-FFF2-40B4-BE49-F238E27FC236}">
-                <a16:creationId xmlns:a16="http://schemas.microsoft.com/office/drawing/2014/main" id="{7A21E726-DE4D-4AD4-9D9A-383A24D85C0E}"/>
+                <a16:creationId xmlns:a16="http://schemas.microsoft.com/office/drawing/2014/main" id="{421D2126-069E-43E7-BFEA-5F83BE26D4D3}"/>
               </a:ext>
             </a:extLst>
           </p:cNvPr>
@@ -2609,7 +2609,7 @@
           <p:cNvPr id="10" name="">
             <a:extLst xmlns:a="http://schemas.openxmlformats.org/drawingml/2006/main">
               <a:ext uri="{FF2B5EF4-FFF2-40B4-BE49-F238E27FC236}">
-                <a16:creationId xmlns:a16="http://schemas.microsoft.com/office/drawing/2014/main" id="{3557DCD6-AFA9-486E-B246-EC9471E41BB3}"/>
+                <a16:creationId xmlns:a16="http://schemas.microsoft.com/office/drawing/2014/main" id="{312BD01D-F4D8-477B-9BC5-97BFF4040466}"/>
               </a:ext>
             </a:extLst>
           </p:cNvPr>
@@ -2659,7 +2659,7 @@
           <p:cNvPr id="11" name="">
             <a:extLst xmlns:a="http://schemas.openxmlformats.org/drawingml/2006/main">
               <a:ext uri="{FF2B5EF4-FFF2-40B4-BE49-F238E27FC236}">
-                <a16:creationId xmlns:a16="http://schemas.microsoft.com/office/drawing/2014/main" id="{E9E5C7C6-DF9E-4838-9F71-3BEFC5729C24}"/>
+                <a16:creationId xmlns:a16="http://schemas.microsoft.com/office/drawing/2014/main" id="{06EDCEB4-D31D-4D90-9F8E-A381D8C4A849}"/>
               </a:ext>
             </a:extLst>
           </p:cNvPr>
@@ -2709,7 +2709,7 @@
           <p:cNvPr id="12" name="">
             <a:extLst xmlns:a="http://schemas.openxmlformats.org/drawingml/2006/main">
               <a:ext uri="{FF2B5EF4-FFF2-40B4-BE49-F238E27FC236}">
-                <a16:creationId xmlns:a16="http://schemas.microsoft.com/office/drawing/2014/main" id="{984322FA-0AF3-44AC-BCB8-D9B1CDD83B9B}"/>
+                <a16:creationId xmlns:a16="http://schemas.microsoft.com/office/drawing/2014/main" id="{5CD27239-9A30-46D0-B3EC-63C3F046A255}"/>
               </a:ext>
             </a:extLst>
           </p:cNvPr>
@@ -2759,7 +2759,7 @@
           <p:cNvPr id="13" name="">
             <a:extLst xmlns:a="http://schemas.openxmlformats.org/drawingml/2006/main">
               <a:ext uri="{FF2B5EF4-FFF2-40B4-BE49-F238E27FC236}">
-                <a16:creationId xmlns:a16="http://schemas.microsoft.com/office/drawing/2014/main" id="{2D6533CA-3626-4B5B-AC04-4FFC19E81CAA}"/>
+                <a16:creationId xmlns:a16="http://schemas.microsoft.com/office/drawing/2014/main" id="{E857246A-464C-452E-A7F7-14973B9FD014}"/>
               </a:ext>
             </a:extLst>
           </p:cNvPr>
@@ -2771,7 +2771,7 @@
         <p:spPr>
           <a:xfrm xmlns:a="http://schemas.openxmlformats.org/drawingml/2006/main">
             <a:off x="895350" y="4362450"/>
-            <a:ext cx="952500" cy="209550"/>
+            <a:ext cx="1714500" cy="209550"/>
           </a:xfrm>
           <a:prstGeom xmlns:a="http://schemas.openxmlformats.org/drawingml/2006/main" prst="rect">
             <a:avLst/>
@@ -2799,7 +2799,7 @@
                   <a:srgbClr val="2878B5"/>
                 </a:solidFill>
               </a:rPr>
-              <a:t>DOWNLOAD</a:t>
+              <a:t>CLASS REPOSITORY</a:t>
             </a:r>
           </a:p>
         </p:txBody>
@@ -2809,7 +2809,7 @@
           <p:cNvPr id="14" name="">
             <a:extLst xmlns:a="http://schemas.openxmlformats.org/drawingml/2006/main">
               <a:ext uri="{FF2B5EF4-FFF2-40B4-BE49-F238E27FC236}">
-                <a16:creationId xmlns:a16="http://schemas.microsoft.com/office/drawing/2014/main" id="{626BA708-1A16-4865-BBBA-CB5BF9ADB267}"/>
+                <a16:creationId xmlns:a16="http://schemas.microsoft.com/office/drawing/2014/main" id="{6438A0C7-F158-4115-A2E0-0E111DD7C723}"/>
               </a:ext>
             </a:extLst>
           </p:cNvPr>
@@ -2849,7 +2849,7 @@
                   <a:srgbClr val="13243A"/>
                 </a:solidFill>
               </a:rPr>
-              <a:t>transtats.bts.gov</a:t>
+              <a:t>github.com/ddicrisi/</a:t>
             </a:r>
           </a:p>
           <a:p xmlns:a="http://schemas.openxmlformats.org/drawingml/2006/main">
@@ -2866,7 +2866,7 @@
                   <a:srgbClr val="13243A"/>
                 </a:solidFill>
               </a:rPr>
-              <a:t>→ Aviation → On-Time Data</a:t>
+              <a:t>dasc605-virginia-airline-delays</a:t>
             </a:r>
           </a:p>
         </p:txBody>
@@ -2876,7 +2876,7 @@
           <p:cNvPr id="15" name="">
             <a:extLst xmlns:a="http://schemas.openxmlformats.org/drawingml/2006/main">
               <a:ext uri="{FF2B5EF4-FFF2-40B4-BE49-F238E27FC236}">
-                <a16:creationId xmlns:a16="http://schemas.microsoft.com/office/drawing/2014/main" id="{A64CEF12-66FF-47FF-9D2B-BC133611E472}"/>
+                <a16:creationId xmlns:a16="http://schemas.microsoft.com/office/drawing/2014/main" id="{FECEFB9A-B88C-4991-8A3F-593BAC06D494}"/>
               </a:ext>
             </a:extLst>
           </p:cNvPr>
@@ -2916,7 +2916,7 @@
                   <a:srgbClr val="536273"/>
                 </a:solidFill>
               </a:rPr>
-              <a:t>The project package includes the compressed dataset, sample, dictionary, and reproducible code.</a:t>
+              <a:t>Includes the compressed dataset, sample, dictionary, presentation, and reproducible code.</a:t>
             </a:r>
           </a:p>
         </p:txBody>
@@ -2926,7 +2926,7 @@
           <p:cNvPr id="16" name="">
             <a:extLst xmlns:a="http://schemas.openxmlformats.org/drawingml/2006/main">
               <a:ext uri="{FF2B5EF4-FFF2-40B4-BE49-F238E27FC236}">
-                <a16:creationId xmlns:a16="http://schemas.microsoft.com/office/drawing/2014/main" id="{EA83B8B4-1760-4E02-ACEF-1C45F465B0C8}"/>
+                <a16:creationId xmlns:a16="http://schemas.microsoft.com/office/drawing/2014/main" id="{5768681D-7C5D-4689-BDB9-5F3833DF43D7}"/>
               </a:ext>
             </a:extLst>
           </p:cNvPr>
@@ -2976,7 +2976,7 @@
           <p:cNvPr id="17" name="">
             <a:extLst xmlns:a="http://schemas.openxmlformats.org/drawingml/2006/main">
               <a:ext uri="{FF2B5EF4-FFF2-40B4-BE49-F238E27FC236}">
-                <a16:creationId xmlns:a16="http://schemas.microsoft.com/office/drawing/2014/main" id="{E7316147-7469-4242-B4C3-3EEE421676BA}"/>
+                <a16:creationId xmlns:a16="http://schemas.microsoft.com/office/drawing/2014/main" id="{E20020CD-BA87-4ECA-BD24-01268AE83B37}"/>
               </a:ext>
             </a:extLst>
           </p:cNvPr>
@@ -3026,7 +3026,7 @@
           <p:cNvPr id="18" name="">
             <a:extLst xmlns:a="http://schemas.openxmlformats.org/drawingml/2006/main">
               <a:ext uri="{FF2B5EF4-FFF2-40B4-BE49-F238E27FC236}">
-                <a16:creationId xmlns:a16="http://schemas.microsoft.com/office/drawing/2014/main" id="{A1F90585-C51F-46A8-BB31-A068474D691D}"/>
+                <a16:creationId xmlns:a16="http://schemas.microsoft.com/office/drawing/2014/main" id="{B3BA2FF9-9178-4E21-8325-D2CFDD0669B7}"/>
               </a:ext>
             </a:extLst>
           </p:cNvPr>
@@ -3110,7 +3110,7 @@
           <p:cNvPr id="19" name="">
             <a:extLst xmlns:a="http://schemas.openxmlformats.org/drawingml/2006/main">
               <a:ext uri="{FF2B5EF4-FFF2-40B4-BE49-F238E27FC236}">
-                <a16:creationId xmlns:a16="http://schemas.microsoft.com/office/drawing/2014/main" id="{91073F4E-6981-41B2-9467-797B1210DF2B}"/>
+                <a16:creationId xmlns:a16="http://schemas.microsoft.com/office/drawing/2014/main" id="{26C55899-4AC0-47D7-AFD6-5662F07BFED9}"/>
               </a:ext>
             </a:extLst>
           </p:cNvPr>
@@ -3160,7 +3160,7 @@
           <p:cNvPr id="20" name="">
             <a:extLst xmlns:a="http://schemas.openxmlformats.org/drawingml/2006/main">
               <a:ext uri="{FF2B5EF4-FFF2-40B4-BE49-F238E27FC236}">
-                <a16:creationId xmlns:a16="http://schemas.microsoft.com/office/drawing/2014/main" id="{79D2DDA8-D0BD-47FD-94BA-E1E373AAECD9}"/>
+                <a16:creationId xmlns:a16="http://schemas.microsoft.com/office/drawing/2014/main" id="{1A804D16-1A2E-442C-A034-F0F21D68C1FB}"/>
               </a:ext>
             </a:extLst>
           </p:cNvPr>
@@ -3244,7 +3244,7 @@
           <p:cNvPr id="21" name="">
             <a:extLst xmlns:a="http://schemas.openxmlformats.org/drawingml/2006/main">
               <a:ext uri="{FF2B5EF4-FFF2-40B4-BE49-F238E27FC236}">
-                <a16:creationId xmlns:a16="http://schemas.microsoft.com/office/drawing/2014/main" id="{2E7BEFBB-50CA-453A-9EB5-CA99E35851EE}"/>
+                <a16:creationId xmlns:a16="http://schemas.microsoft.com/office/drawing/2014/main" id="{92D3E234-BC6E-489B-85F8-B86E35A5E66C}"/>
               </a:ext>
             </a:extLst>
           </p:cNvPr>
@@ -3279,7 +3279,7 @@
           <p:cNvPr id="22" name="">
             <a:extLst xmlns:a="http://schemas.openxmlformats.org/drawingml/2006/main">
               <a:ext uri="{FF2B5EF4-FFF2-40B4-BE49-F238E27FC236}">
-                <a16:creationId xmlns:a16="http://schemas.microsoft.com/office/drawing/2014/main" id="{D6A833EC-873C-42D5-97C3-8349CBA48FBA}"/>
+                <a16:creationId xmlns:a16="http://schemas.microsoft.com/office/drawing/2014/main" id="{DF875BFB-6B8E-41E3-9B2C-EEB07DE1303E}"/>
               </a:ext>
             </a:extLst>
           </p:cNvPr>
@@ -3329,7 +3329,7 @@
           <p:cNvPr id="23" name="">
             <a:extLst xmlns:a="http://schemas.openxmlformats.org/drawingml/2006/main">
               <a:ext uri="{FF2B5EF4-FFF2-40B4-BE49-F238E27FC236}">
-                <a16:creationId xmlns:a16="http://schemas.microsoft.com/office/drawing/2014/main" id="{5C51DF75-AD1C-489A-8867-B5BA687C5C94}"/>
+                <a16:creationId xmlns:a16="http://schemas.microsoft.com/office/drawing/2014/main" id="{EFBEE045-99B8-4270-B179-AAB877E23AD1}"/>
               </a:ext>
             </a:extLst>
           </p:cNvPr>
@@ -3379,7 +3379,7 @@
           <p:cNvPr id="24" name="">
             <a:extLst xmlns:a="http://schemas.openxmlformats.org/drawingml/2006/main">
               <a:ext uri="{FF2B5EF4-FFF2-40B4-BE49-F238E27FC236}">
-                <a16:creationId xmlns:a16="http://schemas.microsoft.com/office/drawing/2014/main" id="{D352974D-5ACA-488F-AA89-C72BD70FE9F6}"/>
+                <a16:creationId xmlns:a16="http://schemas.microsoft.com/office/drawing/2014/main" id="{A60F06DA-D239-4EA8-875B-1698F436E6BC}"/>
               </a:ext>
             </a:extLst>
           </p:cNvPr>
@@ -3429,7 +3429,7 @@
           <p:cNvPr id="25" name="">
             <a:extLst xmlns:a="http://schemas.openxmlformats.org/drawingml/2006/main">
               <a:ext uri="{FF2B5EF4-FFF2-40B4-BE49-F238E27FC236}">
-                <a16:creationId xmlns:a16="http://schemas.microsoft.com/office/drawing/2014/main" id="{70CDB0E9-F714-42F1-B15E-E84E936C8FAD}"/>
+                <a16:creationId xmlns:a16="http://schemas.microsoft.com/office/drawing/2014/main" id="{DD537D7D-243B-401A-A857-6A3A7A1369C7}"/>
               </a:ext>
             </a:extLst>
           </p:cNvPr>
@@ -3479,7 +3479,7 @@
           <p:cNvPr id="26" name="">
             <a:extLst xmlns:a="http://schemas.openxmlformats.org/drawingml/2006/main">
               <a:ext uri="{FF2B5EF4-FFF2-40B4-BE49-F238E27FC236}">
-                <a16:creationId xmlns:a16="http://schemas.microsoft.com/office/drawing/2014/main" id="{ED97E59F-2B08-41BF-82F6-5B54F4A7DA6E}"/>
+                <a16:creationId xmlns:a16="http://schemas.microsoft.com/office/drawing/2014/main" id="{23D7BA55-B88C-482D-9A59-F252735066F3}"/>
               </a:ext>
             </a:extLst>
           </p:cNvPr>
@@ -3529,7 +3529,7 @@
           <p:cNvPr id="27" name="">
             <a:extLst xmlns:a="http://schemas.openxmlformats.org/drawingml/2006/main">
               <a:ext uri="{FF2B5EF4-FFF2-40B4-BE49-F238E27FC236}">
-                <a16:creationId xmlns:a16="http://schemas.microsoft.com/office/drawing/2014/main" id="{98CC1795-7958-4BA2-9784-42670D86512C}"/>
+                <a16:creationId xmlns:a16="http://schemas.microsoft.com/office/drawing/2014/main" id="{29627591-36F0-4188-862E-8A00DDDE1A76}"/>
               </a:ext>
             </a:extLst>
           </p:cNvPr>
@@ -3579,7 +3579,7 @@
           <p:cNvPr id="28" name="">
             <a:extLst xmlns:a="http://schemas.openxmlformats.org/drawingml/2006/main">
               <a:ext uri="{FF2B5EF4-FFF2-40B4-BE49-F238E27FC236}">
-                <a16:creationId xmlns:a16="http://schemas.microsoft.com/office/drawing/2014/main" id="{53A43D9B-5E6D-4CA7-94EC-BEDAF53AFF80}"/>
+                <a16:creationId xmlns:a16="http://schemas.microsoft.com/office/drawing/2014/main" id="{88AF8F5B-EE34-41F4-B069-96FA0BADF1C0}"/>
               </a:ext>
             </a:extLst>
           </p:cNvPr>
@@ -3629,7 +3629,7 @@
           <p:cNvPr id="29" name="">
             <a:extLst xmlns:a="http://schemas.openxmlformats.org/drawingml/2006/main">
               <a:ext uri="{FF2B5EF4-FFF2-40B4-BE49-F238E27FC236}">
-                <a16:creationId xmlns:a16="http://schemas.microsoft.com/office/drawing/2014/main" id="{4D13451C-5DA9-4158-AD40-7EF5F2448991}"/>
+                <a16:creationId xmlns:a16="http://schemas.microsoft.com/office/drawing/2014/main" id="{CCE2A5BD-FB47-4636-B9BC-B6FDB1256E40}"/>
               </a:ext>
             </a:extLst>
           </p:cNvPr>
@@ -3679,7 +3679,7 @@
           <p:cNvPr id="30" name="">
             <a:extLst xmlns:a="http://schemas.openxmlformats.org/drawingml/2006/main">
               <a:ext uri="{FF2B5EF4-FFF2-40B4-BE49-F238E27FC236}">
-                <a16:creationId xmlns:a16="http://schemas.microsoft.com/office/drawing/2014/main" id="{5F3A9D29-BB54-49D0-A4E8-D53F57DBF782}"/>
+                <a16:creationId xmlns:a16="http://schemas.microsoft.com/office/drawing/2014/main" id="{C31A6B95-DE18-4F25-90FC-2C042E817912}"/>
               </a:ext>
             </a:extLst>
           </p:cNvPr>
@@ -3729,7 +3729,7 @@
           <p:cNvPr id="31" name="">
             <a:extLst xmlns:a="http://schemas.openxmlformats.org/drawingml/2006/main">
               <a:ext uri="{FF2B5EF4-FFF2-40B4-BE49-F238E27FC236}">
-                <a16:creationId xmlns:a16="http://schemas.microsoft.com/office/drawing/2014/main" id="{D712BEB5-EF4E-46DF-9E1A-916B09A31998}"/>
+                <a16:creationId xmlns:a16="http://schemas.microsoft.com/office/drawing/2014/main" id="{011D9321-B366-461E-8C3F-51852336D87F}"/>
               </a:ext>
             </a:extLst>
           </p:cNvPr>
@@ -3777,7 +3777,7 @@
     </p:spTree>
     <p:extLst>
       <p:ext uri="{BB962C8B-B14F-4D97-AF65-F5344CB8AC3E}">
-        <p14:creationId xmlns:p14="http://schemas.microsoft.com/office/powerpoint/2010/main" val="2090203883"/>
+        <p14:creationId xmlns:p14="http://schemas.microsoft.com/office/powerpoint/2010/main" val="406533878"/>
       </p:ext>
     </p:extLst>
   </p:cSld>

</xml_diff>